<commit_message>
Reporte portadas en pptx
</commit_message>
<xml_diff>
--- a/Reporte 170826.pptx
+++ b/Reporte 170826.pptx
@@ -6420,7 +6420,7 @@
                 <a:latin typeface="Montserrat Black"/>
                 <a:sym typeface="Arial"/>
               </a:rPr>
-              <a:t>Elaborado: 14</a:t>
+              <a:t>Elaborado: 17</a:t>
             </a:r>
             <a:r>
               <a:rPr lang="es-MX" sz="1600" dirty="0">
@@ -7376,10 +7376,10 @@
       </p:sp>
       <p:pic>
         <p:nvPicPr>
-          <p:cNvPr id="3" name="Imagen 2">
+          <p:cNvPr id="4" name="Imagen 3">
             <a:extLst>
               <a:ext uri="{FF2B5EF4-FFF2-40B4-BE49-F238E27FC236}">
-                <a16:creationId xmlns:a16="http://schemas.microsoft.com/office/drawing/2014/main" id="{FE491FB3-5A2D-D429-E608-CE5A06AD3A07}"/>
+                <a16:creationId xmlns:a16="http://schemas.microsoft.com/office/drawing/2014/main" id="{11F137E2-06CC-A23B-C739-52D5CBCEBA21}"/>
               </a:ext>
             </a:extLst>
           </p:cNvPr>
@@ -7396,8 +7396,8 @@
         </p:blipFill>
         <p:spPr>
           <a:xfrm>
-            <a:off x="-36512" y="929619"/>
-            <a:ext cx="9144000" cy="3427137"/>
+            <a:off x="0" y="947841"/>
+            <a:ext cx="9144000" cy="3390694"/>
           </a:xfrm>
           <a:prstGeom prst="rect">
             <a:avLst/>
@@ -7490,10 +7490,10 @@
       </p:sp>
       <p:pic>
         <p:nvPicPr>
-          <p:cNvPr id="4" name="Imagen 3">
+          <p:cNvPr id="6" name="Imagen 5">
             <a:extLst>
               <a:ext uri="{FF2B5EF4-FFF2-40B4-BE49-F238E27FC236}">
-                <a16:creationId xmlns:a16="http://schemas.microsoft.com/office/drawing/2014/main" id="{7B060FFE-2014-7E7D-11B7-788F7F0D28DD}"/>
+                <a16:creationId xmlns:a16="http://schemas.microsoft.com/office/drawing/2014/main" id="{378FC8FA-B0C8-D611-F836-EE7503A7AAF8}"/>
               </a:ext>
             </a:extLst>
           </p:cNvPr>
@@ -7510,8 +7510,8 @@
         </p:blipFill>
         <p:spPr>
           <a:xfrm>
-            <a:off x="0" y="1422496"/>
-            <a:ext cx="9144000" cy="2441383"/>
+            <a:off x="0" y="1413889"/>
+            <a:ext cx="9144000" cy="2458598"/>
           </a:xfrm>
           <a:prstGeom prst="rect">
             <a:avLst/>
@@ -7604,10 +7604,10 @@
       </p:sp>
       <p:pic>
         <p:nvPicPr>
-          <p:cNvPr id="3" name="Imagen 2">
+          <p:cNvPr id="2" name="Imagen 1">
             <a:extLst>
               <a:ext uri="{FF2B5EF4-FFF2-40B4-BE49-F238E27FC236}">
-                <a16:creationId xmlns:a16="http://schemas.microsoft.com/office/drawing/2014/main" id="{905A78A1-1B48-401F-E1A2-D01FA96E34D0}"/>
+                <a16:creationId xmlns:a16="http://schemas.microsoft.com/office/drawing/2014/main" id="{07D08A58-055D-83F5-A37C-A4E7A69EA015}"/>
               </a:ext>
             </a:extLst>
           </p:cNvPr>
@@ -7624,8 +7624,8 @@
         </p:blipFill>
         <p:spPr>
           <a:xfrm>
-            <a:off x="560314" y="639664"/>
-            <a:ext cx="7950347" cy="4007048"/>
+            <a:off x="1106488" y="914940"/>
+            <a:ext cx="6858000" cy="3456495"/>
           </a:xfrm>
           <a:prstGeom prst="rect">
             <a:avLst/>
@@ -7714,10 +7714,10 @@
       </p:sp>
       <p:pic>
         <p:nvPicPr>
-          <p:cNvPr id="3" name="Imagen 2">
+          <p:cNvPr id="4" name="Imagen 3">
             <a:extLst>
               <a:ext uri="{FF2B5EF4-FFF2-40B4-BE49-F238E27FC236}">
-                <a16:creationId xmlns:a16="http://schemas.microsoft.com/office/drawing/2014/main" id="{88528215-3D9E-1EE7-FB86-9C0C74A4D0BC}"/>
+                <a16:creationId xmlns:a16="http://schemas.microsoft.com/office/drawing/2014/main" id="{869F472D-D6DE-B83E-A4B5-C9098199A45E}"/>
               </a:ext>
             </a:extLst>
           </p:cNvPr>
@@ -7734,8 +7734,8 @@
         </p:blipFill>
         <p:spPr>
           <a:xfrm>
-            <a:off x="1969283" y="707587"/>
-            <a:ext cx="5132408" cy="3871202"/>
+            <a:off x="520139" y="1180896"/>
+            <a:ext cx="8030696" cy="2924583"/>
           </a:xfrm>
           <a:prstGeom prst="rect">
             <a:avLst/>
@@ -7828,10 +7828,10 @@
       </p:sp>
       <p:pic>
         <p:nvPicPr>
-          <p:cNvPr id="3" name="Imagen 2">
+          <p:cNvPr id="9" name="Imagen 8">
             <a:extLst>
               <a:ext uri="{FF2B5EF4-FFF2-40B4-BE49-F238E27FC236}">
-                <a16:creationId xmlns:a16="http://schemas.microsoft.com/office/drawing/2014/main" id="{E281D56F-57D3-FD3B-B949-2CD757D901AE}"/>
+                <a16:creationId xmlns:a16="http://schemas.microsoft.com/office/drawing/2014/main" id="{D986BD78-D11D-77B5-8845-BF9D3302CBE4}"/>
               </a:ext>
             </a:extLst>
           </p:cNvPr>
@@ -7848,8 +7848,8 @@
         </p:blipFill>
         <p:spPr>
           <a:xfrm>
-            <a:off x="0" y="1480658"/>
-            <a:ext cx="9144000" cy="2441383"/>
+            <a:off x="0" y="988623"/>
+            <a:ext cx="9144000" cy="3411054"/>
           </a:xfrm>
           <a:prstGeom prst="rect">
             <a:avLst/>
@@ -7942,10 +7942,10 @@
       </p:sp>
       <p:pic>
         <p:nvPicPr>
-          <p:cNvPr id="2" name="Imagen 1">
+          <p:cNvPr id="3" name="Imagen 2">
             <a:extLst>
               <a:ext uri="{FF2B5EF4-FFF2-40B4-BE49-F238E27FC236}">
-                <a16:creationId xmlns:a16="http://schemas.microsoft.com/office/drawing/2014/main" id="{9C1CCAA9-301C-8B36-8E65-297723B1C05C}"/>
+                <a16:creationId xmlns:a16="http://schemas.microsoft.com/office/drawing/2014/main" id="{2708BF77-28C6-DCE6-69AB-59153B77A1A3}"/>
               </a:ext>
             </a:extLst>
           </p:cNvPr>
@@ -7962,7 +7962,7 @@
         </p:blipFill>
         <p:spPr>
           <a:xfrm>
-            <a:off x="1143000" y="914940"/>
+            <a:off x="1106488" y="914940"/>
             <a:ext cx="6858000" cy="3456495"/>
           </a:xfrm>
           <a:prstGeom prst="rect">
@@ -8056,10 +8056,10 @@
       </p:sp>
       <p:pic>
         <p:nvPicPr>
-          <p:cNvPr id="2" name="Imagen 1">
+          <p:cNvPr id="3" name="Imagen 2">
             <a:extLst>
               <a:ext uri="{FF2B5EF4-FFF2-40B4-BE49-F238E27FC236}">
-                <a16:creationId xmlns:a16="http://schemas.microsoft.com/office/drawing/2014/main" id="{112FEE0C-77F0-AE11-E4A8-C891897998F1}"/>
+                <a16:creationId xmlns:a16="http://schemas.microsoft.com/office/drawing/2014/main" id="{DAC7DEA0-F7A5-2874-B3C3-A1FEEE8D320D}"/>
               </a:ext>
             </a:extLst>
           </p:cNvPr>
@@ -8174,10 +8174,10 @@
       </p:sp>
       <p:pic>
         <p:nvPicPr>
-          <p:cNvPr id="5" name="Imagen 4">
+          <p:cNvPr id="3" name="Imagen 2">
             <a:extLst>
               <a:ext uri="{FF2B5EF4-FFF2-40B4-BE49-F238E27FC236}">
-                <a16:creationId xmlns:a16="http://schemas.microsoft.com/office/drawing/2014/main" id="{043F8905-0C13-0CEC-1F04-79293DCEF416}"/>
+                <a16:creationId xmlns:a16="http://schemas.microsoft.com/office/drawing/2014/main" id="{183C01EE-6710-DFBF-FCA7-1CA1806C5609}"/>
               </a:ext>
             </a:extLst>
           </p:cNvPr>
@@ -8194,8 +8194,8 @@
         </p:blipFill>
         <p:spPr>
           <a:xfrm>
-            <a:off x="1957022" y="1509564"/>
-            <a:ext cx="5229955" cy="2124371"/>
+            <a:off x="2558773" y="1695318"/>
+            <a:ext cx="3953427" cy="1895740"/>
           </a:xfrm>
           <a:prstGeom prst="rect">
             <a:avLst/>

</xml_diff>